<commit_message>
Depth refresh 2026-08-11: OurLads re-scrape ahead of Week 0
All 138 teams captured (Utah State included), workbook depth panels
rebuilt and recalced, decks regenerated. The depth data itself stays
local (ourlads_depth.json gitignored); this commit carries the rebuilt
workbook and the tracked overview deck.

Co-Authored-By: Claude Fable 5 <noreply@anthropic.com>
</commit_message>
<xml_diff>
--- a/decks/2026_Season_Sim_Overview.pptx
+++ b/decks/2026_Season_Sim_Overview.pptx
@@ -154,13 +154,13 @@
                   <c:v>Pac-12</c:v>
                 </c:pt>
                 <c:pt idx="3">
-                  <c:v>SEC</c:v>
+                  <c:v>Mountain West</c:v>
                 </c:pt>
                 <c:pt idx="4">
                   <c:v>Big Ten</c:v>
                 </c:pt>
                 <c:pt idx="5">
-                  <c:v>Mountain West</c:v>
+                  <c:v>SEC</c:v>
                 </c:pt>
                 <c:pt idx="6">
                   <c:v>Mid-American</c:v>
@@ -184,34 +184,34 @@
                 <c:formatCode>General</c:formatCode>
                 <c:ptCount val="10"/>
                 <c:pt idx="0">
-                  <c:v>0.3591</c:v>
+                  <c:v>0.3565</c:v>
                 </c:pt>
                 <c:pt idx="1">
-                  <c:v>0.4206</c:v>
+                  <c:v>0.4119</c:v>
                 </c:pt>
                 <c:pt idx="2">
-                  <c:v>0.498</c:v>
+                  <c:v>0.5006</c:v>
                 </c:pt>
                 <c:pt idx="3">
-                  <c:v>0.5085</c:v>
+                  <c:v>0.5127</c:v>
                 </c:pt>
                 <c:pt idx="4">
-                  <c:v>0.5157</c:v>
+                  <c:v>0.5136</c:v>
                 </c:pt>
                 <c:pt idx="5">
-                  <c:v>0.5173</c:v>
+                  <c:v>0.5179</c:v>
                 </c:pt>
                 <c:pt idx="6">
-                  <c:v>0.5547</c:v>
+                  <c:v>0.5615</c:v>
                 </c:pt>
                 <c:pt idx="7">
-                  <c:v>0.5705</c:v>
+                  <c:v>0.5671</c:v>
                 </c:pt>
                 <c:pt idx="8">
-                  <c:v>0.5896</c:v>
+                  <c:v>0.5868</c:v>
                 </c:pt>
                 <c:pt idx="9">
-                  <c:v>0.6091</c:v>
+                  <c:v>0.6024</c:v>
                 </c:pt>
               </c:numCache>
             </c:numRef>
@@ -4199,7 +4199,7 @@
                           </a:solidFill>
                           <a:latin typeface="Arial"/>
                         </a:rPr>
-                        <a:t>51%</a:t>
+                        <a:t>52%</a:t>
                       </a:r>
                     </a:p>
                   </a:txBody>
@@ -4316,7 +4316,7 @@
                           </a:solidFill>
                           <a:latin typeface="Arial"/>
                         </a:rPr>
-                        <a:t>52%</a:t>
+                        <a:t>51%</a:t>
                       </a:r>
                     </a:p>
                   </a:txBody>
@@ -4387,7 +4387,7 @@
                           </a:solidFill>
                           <a:latin typeface="Arial"/>
                         </a:rPr>
-                        <a:t>66%</a:t>
+                        <a:t>65%</a:t>
                       </a:r>
                     </a:p>
                   </a:txBody>
@@ -4504,7 +4504,7 @@
                           </a:solidFill>
                           <a:latin typeface="Arial"/>
                         </a:rPr>
-                        <a:t>68%</a:t>
+                        <a:t>69%</a:t>
                       </a:r>
                     </a:p>
                   </a:txBody>
@@ -4550,7 +4550,7 @@
                           </a:solidFill>
                           <a:latin typeface="Arial"/>
                         </a:rPr>
-                        <a:t>42%</a:t>
+                        <a:t>41%</a:t>
                       </a:r>
                     </a:p>
                   </a:txBody>
@@ -4784,7 +4784,7 @@
                           </a:solidFill>
                           <a:latin typeface="Arial"/>
                         </a:rPr>
-                        <a:t>61%</a:t>
+                        <a:t>60%</a:t>
                       </a:r>
                     </a:p>
                   </a:txBody>
@@ -4901,7 +4901,7 @@
                           </a:solidFill>
                           <a:latin typeface="Arial"/>
                         </a:rPr>
-                        <a:t>52%</a:t>
+                        <a:t>51%</a:t>
                       </a:r>
                     </a:p>
                   </a:txBody>
@@ -5089,7 +5089,7 @@
                           </a:solidFill>
                           <a:latin typeface="Arial"/>
                         </a:rPr>
-                        <a:t>30%</a:t>
+                        <a:t>32%</a:t>
                       </a:r>
                     </a:p>
                   </a:txBody>
@@ -5252,7 +5252,7 @@
                           </a:solidFill>
                           <a:latin typeface="Arial"/>
                         </a:rPr>
-                        <a:t>55%</a:t>
+                        <a:t>56%</a:t>
                       </a:r>
                     </a:p>
                   </a:txBody>
@@ -5623,7 +5623,7 @@
                           </a:solidFill>
                           <a:latin typeface="Arial"/>
                         </a:rPr>
-                        <a:t>95%</a:t>
+                        <a:t>96%</a:t>
                       </a:r>
                     </a:p>
                   </a:txBody>
@@ -5740,7 +5740,7 @@
                           </a:solidFill>
                           <a:latin typeface="Arial"/>
                         </a:rPr>
-                        <a:t>10.7</a:t>
+                        <a:t>10.8</a:t>
                       </a:r>
                     </a:p>
                   </a:txBody>
@@ -5903,7 +5903,7 @@
                           </a:solidFill>
                           <a:latin typeface="Arial"/>
                         </a:rPr>
-                        <a:t>79%</a:t>
+                        <a:t>80%</a:t>
                       </a:r>
                     </a:p>
                   </a:txBody>
@@ -6043,7 +6043,7 @@
                           </a:solidFill>
                           <a:latin typeface="Arial"/>
                         </a:rPr>
-                        <a:t>77%</a:t>
+                        <a:t>78%</a:t>
                       </a:r>
                     </a:p>
                   </a:txBody>
@@ -6603,7 +6603,7 @@
                           </a:solidFill>
                           <a:latin typeface="Arial"/>
                         </a:rPr>
-                        <a:t>59%</a:t>
+                        <a:t>60%</a:t>
                       </a:r>
                     </a:p>
                   </a:txBody>
@@ -6720,7 +6720,7 @@
                           </a:solidFill>
                           <a:latin typeface="Arial"/>
                         </a:rPr>
-                        <a:t>9.2</a:t>
+                        <a:t>9.3</a:t>
                       </a:r>
                     </a:p>
                   </a:txBody>
@@ -7023,7 +7023,7 @@
                           </a:solidFill>
                           <a:latin typeface="Arial"/>
                         </a:rPr>
-                        <a:t>32%</a:t>
+                        <a:t>31%</a:t>
                       </a:r>
                     </a:p>
                   </a:txBody>
@@ -7303,7 +7303,7 @@
                           </a:solidFill>
                           <a:latin typeface="Arial"/>
                         </a:rPr>
-                        <a:t>27%</a:t>
+                        <a:t>26%</a:t>
                       </a:r>
                     </a:p>
                   </a:txBody>
@@ -8641,7 +8641,7 @@
                           </a:solidFill>
                           <a:latin typeface="Arial"/>
                         </a:rPr>
-                        <a:t>Navy</a:t>
+                        <a:t>East Carolina</a:t>
                       </a:r>
                     </a:p>
                   </a:txBody>
@@ -8733,7 +8733,7 @@
                           </a:solidFill>
                           <a:latin typeface="Arial"/>
                         </a:rPr>
-                        <a:t>16%</a:t>
+                        <a:t>15%</a:t>
                       </a:r>
                     </a:p>
                   </a:txBody>
@@ -8781,7 +8781,7 @@
                           </a:solidFill>
                           <a:latin typeface="Arial"/>
                         </a:rPr>
-                        <a:t>East Carolina</a:t>
+                        <a:t>Navy</a:t>
                       </a:r>
                     </a:p>
                   </a:txBody>
@@ -8873,7 +8873,7 @@
                           </a:solidFill>
                           <a:latin typeface="Arial"/>
                         </a:rPr>
-                        <a:t>15%</a:t>
+                        <a:t>16%</a:t>
                       </a:r>
                     </a:p>
                   </a:txBody>

</xml_diff>

<commit_message>
Empirical margin curve adoption: Season Sim, sim decks, ep deck on curve; Kelly sizing
Season Sim + conference sims moved from Normal(0, 13.5) to the fitted
margin curve (residual sd 17.94); UNRATED_MARGIN recalibrated 24 -> 29 to
match the actual 94.4% FBS-over-FCS rate; edge_report gains --kelly/--bank
stake sizing; workbook, decks, and watch-list ledger regenerated.

Co-Authored-By: Claude Fable 5 <noreply@anthropic.com>
</commit_message>
<xml_diff>
--- a/decks/2026_Season_Sim_Overview.pptx
+++ b/decks/2026_Season_Sim_Overview.pptx
@@ -151,25 +151,25 @@
                   <c:v>ACC</c:v>
                 </c:pt>
                 <c:pt idx="2">
+                  <c:v>Big Ten</c:v>
+                </c:pt>
+                <c:pt idx="3">
                   <c:v>Pac-12</c:v>
                 </c:pt>
-                <c:pt idx="3">
-                  <c:v>Mountain West</c:v>
-                </c:pt>
                 <c:pt idx="4">
-                  <c:v>Big Ten</c:v>
+                  <c:v>SEC</c:v>
                 </c:pt>
                 <c:pt idx="5">
-                  <c:v>SEC</c:v>
+                  <c:v>Mountain West</c:v>
                 </c:pt>
                 <c:pt idx="6">
                   <c:v>Mid-American</c:v>
                 </c:pt>
                 <c:pt idx="7">
-                  <c:v>Sun Belt</c:v>
+                  <c:v>Conference USA</c:v>
                 </c:pt>
                 <c:pt idx="8">
-                  <c:v>Conference USA</c:v>
+                  <c:v>Sun Belt</c:v>
                 </c:pt>
                 <c:pt idx="9">
                   <c:v>American</c:v>
@@ -184,34 +184,34 @@
                 <c:formatCode>General</c:formatCode>
                 <c:ptCount val="10"/>
                 <c:pt idx="0">
-                  <c:v>0.3565</c:v>
+                  <c:v>0.433</c:v>
                 </c:pt>
                 <c:pt idx="1">
-                  <c:v>0.4119</c:v>
+                  <c:v>0.4736</c:v>
                 </c:pt>
                 <c:pt idx="2">
-                  <c:v>0.5006</c:v>
+                  <c:v>0.519</c:v>
                 </c:pt>
                 <c:pt idx="3">
-                  <c:v>0.5127</c:v>
+                  <c:v>0.527</c:v>
                 </c:pt>
                 <c:pt idx="4">
-                  <c:v>0.5136</c:v>
+                  <c:v>0.5275</c:v>
                 </c:pt>
                 <c:pt idx="5">
-                  <c:v>0.5179</c:v>
+                  <c:v>0.5432</c:v>
                 </c:pt>
                 <c:pt idx="6">
-                  <c:v>0.5615</c:v>
+                  <c:v>0.5784</c:v>
                 </c:pt>
                 <c:pt idx="7">
-                  <c:v>0.5671</c:v>
+                  <c:v>0.587</c:v>
                 </c:pt>
                 <c:pt idx="8">
-                  <c:v>0.5868</c:v>
+                  <c:v>0.5896</c:v>
                 </c:pt>
                 <c:pt idx="9">
-                  <c:v>0.6024</c:v>
+                  <c:v>0.6081</c:v>
                 </c:pt>
               </c:numCache>
             </c:numRef>
@@ -3402,7 +3402,19 @@
                 </a:solidFill>
                 <a:latin typeface="Arial"/>
               </a:rPr>
-              <a:t>Prior: ESPN 2026 preseason FPI (July 14 snapshot) · margins ~ N(FPI gap + 2.5 HFA, σ = 13.5)</a:t>
+              <a:t>Prior: ESPN 2026 preseason FPI (July 14) · margins = FPI gap + 2.5 HFA + empirical residuals (σ 17.9)</a:t>
+            </a:r>
+          </a:p>
+          <a:p>
+            <a:pPr algn="l"/>
+            <a:r>
+              <a:rPr sz="1500" b="0" i="0">
+                <a:solidFill>
+                  <a:srgbClr val="CADCFC"/>
+                </a:solidFill>
+                <a:latin typeface="Arial"/>
+              </a:rPr>
+              <a:t>Predictions frozen at kickoff of the 2026 opener — Aug 29</a:t>
             </a:r>
           </a:p>
         </p:txBody>
@@ -3675,7 +3687,7 @@
                 </a:solidFill>
                 <a:latin typeface="Arial"/>
               </a:rPr>
-              <a:t>σ 13.5</a:t>
+              <a:t>σ 17.9</a:t>
             </a:r>
           </a:p>
         </p:txBody>
@@ -3710,7 +3722,7 @@
                 </a:solidFill>
                 <a:latin typeface="Arial"/>
               </a:rPr>
-              <a:t>margin sd vs spread</a:t>
+              <a:t>empirical margin sd, 2021–25 fit</a:t>
             </a:r>
           </a:p>
         </p:txBody>
@@ -4153,7 +4165,7 @@
                           </a:solidFill>
                           <a:latin typeface="Arial"/>
                         </a:rPr>
-                        <a:t>38%</a:t>
+                        <a:t>32%</a:t>
                       </a:r>
                     </a:p>
                   </a:txBody>
@@ -4199,7 +4211,7 @@
                           </a:solidFill>
                           <a:latin typeface="Arial"/>
                         </a:rPr>
-                        <a:t>52%</a:t>
+                        <a:t>53%</a:t>
                       </a:r>
                     </a:p>
                   </a:txBody>
@@ -4270,7 +4282,7 @@
                           </a:solidFill>
                           <a:latin typeface="Arial"/>
                         </a:rPr>
-                        <a:t>42%</a:t>
+                        <a:t>37%</a:t>
                       </a:r>
                     </a:p>
                   </a:txBody>
@@ -4316,7 +4328,7 @@
                           </a:solidFill>
                           <a:latin typeface="Arial"/>
                         </a:rPr>
-                        <a:t>51%</a:t>
+                        <a:t>52%</a:t>
                       </a:r>
                     </a:p>
                   </a:txBody>
@@ -4387,7 +4399,7 @@
                           </a:solidFill>
                           <a:latin typeface="Arial"/>
                         </a:rPr>
-                        <a:t>65%</a:t>
+                        <a:t>53%</a:t>
                       </a:r>
                     </a:p>
                   </a:txBody>
@@ -4433,7 +4445,7 @@
                           </a:solidFill>
                           <a:latin typeface="Arial"/>
                         </a:rPr>
-                        <a:t>36%</a:t>
+                        <a:t>43%</a:t>
                       </a:r>
                     </a:p>
                   </a:txBody>
@@ -4504,7 +4516,7 @@
                           </a:solidFill>
                           <a:latin typeface="Arial"/>
                         </a:rPr>
-                        <a:t>69%</a:t>
+                        <a:t>56%</a:t>
                       </a:r>
                     </a:p>
                   </a:txBody>
@@ -4550,7 +4562,7 @@
                           </a:solidFill>
                           <a:latin typeface="Arial"/>
                         </a:rPr>
-                        <a:t>41%</a:t>
+                        <a:t>47%</a:t>
                       </a:r>
                     </a:p>
                   </a:txBody>
@@ -4621,7 +4633,7 @@
                           </a:solidFill>
                           <a:latin typeface="Arial"/>
                         </a:rPr>
-                        <a:t>47%</a:t>
+                        <a:t>40%</a:t>
                       </a:r>
                     </a:p>
                   </a:txBody>
@@ -4667,7 +4679,7 @@
                           </a:solidFill>
                           <a:latin typeface="Arial"/>
                         </a:rPr>
-                        <a:t>50%</a:t>
+                        <a:t>53%</a:t>
                       </a:r>
                     </a:p>
                   </a:txBody>
@@ -4738,7 +4750,7 @@
                           </a:solidFill>
                           <a:latin typeface="Arial"/>
                         </a:rPr>
-                        <a:t>30%</a:t>
+                        <a:t>24%</a:t>
                       </a:r>
                     </a:p>
                   </a:txBody>
@@ -4784,7 +4796,7 @@
                           </a:solidFill>
                           <a:latin typeface="Arial"/>
                         </a:rPr>
-                        <a:t>60%</a:t>
+                        <a:t>61%</a:t>
                       </a:r>
                     </a:p>
                   </a:txBody>
@@ -4855,7 +4867,7 @@
                           </a:solidFill>
                           <a:latin typeface="Arial"/>
                         </a:rPr>
-                        <a:t>47%</a:t>
+                        <a:t>41%</a:t>
                       </a:r>
                     </a:p>
                   </a:txBody>
@@ -4901,7 +4913,7 @@
                           </a:solidFill>
                           <a:latin typeface="Arial"/>
                         </a:rPr>
-                        <a:t>51%</a:t>
+                        <a:t>54%</a:t>
                       </a:r>
                     </a:p>
                   </a:txBody>
@@ -4972,7 +4984,7 @@
                           </a:solidFill>
                           <a:latin typeface="Arial"/>
                         </a:rPr>
-                        <a:t>28%</a:t>
+                        <a:t>22%</a:t>
                       </a:r>
                     </a:p>
                   </a:txBody>
@@ -5018,7 +5030,7 @@
                           </a:solidFill>
                           <a:latin typeface="Arial"/>
                         </a:rPr>
-                        <a:t>57%</a:t>
+                        <a:t>59%</a:t>
                       </a:r>
                     </a:p>
                   </a:txBody>
@@ -5089,7 +5101,7 @@
                           </a:solidFill>
                           <a:latin typeface="Arial"/>
                         </a:rPr>
-                        <a:t>32%</a:t>
+                        <a:t>27%</a:t>
                       </a:r>
                     </a:p>
                   </a:txBody>
@@ -5206,7 +5218,7 @@
                           </a:solidFill>
                           <a:latin typeface="Arial"/>
                         </a:rPr>
-                        <a:t>35%</a:t>
+                        <a:t>30%</a:t>
                       </a:r>
                     </a:p>
                   </a:txBody>
@@ -5252,7 +5264,7 @@
                           </a:solidFill>
                           <a:latin typeface="Arial"/>
                         </a:rPr>
-                        <a:t>56%</a:t>
+                        <a:t>58%</a:t>
                       </a:r>
                     </a:p>
                   </a:txBody>
@@ -5600,30 +5612,30 @@
                           </a:solidFill>
                           <a:latin typeface="Arial"/>
                         </a:rPr>
-                        <a:t>11.1</a:t>
-                      </a:r>
-                    </a:p>
-                  </a:txBody>
-                  <a:tcPr>
-                    <a:solidFill>
-                      <a:srgbClr val="FFFFFF"/>
-                    </a:solidFill>
-                  </a:tcPr>
-                </a:tc>
-                <a:tc>
-                  <a:txBody>
-                    <a:bodyPr/>
-                    <a:lstStyle/>
-                    <a:p>
-                      <a:pPr algn="ctr"/>
-                      <a:r>
-                        <a:rPr sz="1000">
-                          <a:solidFill>
-                            <a:srgbClr val="16273D"/>
-                          </a:solidFill>
-                          <a:latin typeface="Arial"/>
-                        </a:rPr>
-                        <a:t>96%</a:t>
+                        <a:t>10.5</a:t>
+                      </a:r>
+                    </a:p>
+                  </a:txBody>
+                  <a:tcPr>
+                    <a:solidFill>
+                      <a:srgbClr val="FFFFFF"/>
+                    </a:solidFill>
+                  </a:tcPr>
+                </a:tc>
+                <a:tc>
+                  <a:txBody>
+                    <a:bodyPr/>
+                    <a:lstStyle/>
+                    <a:p>
+                      <a:pPr algn="ctr"/>
+                      <a:r>
+                        <a:rPr sz="1000">
+                          <a:solidFill>
+                            <a:srgbClr val="16273D"/>
+                          </a:solidFill>
+                          <a:latin typeface="Arial"/>
+                        </a:rPr>
+                        <a:t>83%</a:t>
                       </a:r>
                     </a:p>
                   </a:txBody>
@@ -5740,7 +5752,7 @@
                           </a:solidFill>
                           <a:latin typeface="Arial"/>
                         </a:rPr>
-                        <a:t>10.8</a:t>
+                        <a:t>10.1</a:t>
                       </a:r>
                     </a:p>
                   </a:txBody>
@@ -5763,7 +5775,7 @@
                           </a:solidFill>
                           <a:latin typeface="Arial"/>
                         </a:rPr>
-                        <a:t>88%</a:t>
+                        <a:t>70%</a:t>
                       </a:r>
                     </a:p>
                   </a:txBody>
@@ -5880,30 +5892,30 @@
                           </a:solidFill>
                           <a:latin typeface="Arial"/>
                         </a:rPr>
-                        <a:t>10.3</a:t>
-                      </a:r>
-                    </a:p>
-                  </a:txBody>
-                  <a:tcPr>
-                    <a:solidFill>
-                      <a:srgbClr val="FFFFFF"/>
-                    </a:solidFill>
-                  </a:tcPr>
-                </a:tc>
-                <a:tc>
-                  <a:txBody>
-                    <a:bodyPr/>
-                    <a:lstStyle/>
-                    <a:p>
-                      <a:pPr algn="ctr"/>
-                      <a:r>
-                        <a:rPr sz="1000">
-                          <a:solidFill>
-                            <a:srgbClr val="16273D"/>
-                          </a:solidFill>
-                          <a:latin typeface="Arial"/>
-                        </a:rPr>
-                        <a:t>80%</a:t>
+                        <a:t>9.8</a:t>
+                      </a:r>
+                    </a:p>
+                  </a:txBody>
+                  <a:tcPr>
+                    <a:solidFill>
+                      <a:srgbClr val="FFFFFF"/>
+                    </a:solidFill>
+                  </a:tcPr>
+                </a:tc>
+                <a:tc>
+                  <a:txBody>
+                    <a:bodyPr/>
+                    <a:lstStyle/>
+                    <a:p>
+                      <a:pPr algn="ctr"/>
+                      <a:r>
+                        <a:rPr sz="1000">
+                          <a:solidFill>
+                            <a:srgbClr val="16273D"/>
+                          </a:solidFill>
+                          <a:latin typeface="Arial"/>
+                        </a:rPr>
+                        <a:t>61%</a:t>
                       </a:r>
                     </a:p>
                   </a:txBody>
@@ -5951,7 +5963,7 @@
                           </a:solidFill>
                           <a:latin typeface="Arial"/>
                         </a:rPr>
-                        <a:t>Miami</a:t>
+                        <a:t>Indiana</a:t>
                       </a:r>
                     </a:p>
                   </a:txBody>
@@ -5974,7 +5986,7 @@
                           </a:solidFill>
                           <a:latin typeface="Arial"/>
                         </a:rPr>
-                        <a:t>ACC</a:t>
+                        <a:t>Big Ten</a:t>
                       </a:r>
                     </a:p>
                   </a:txBody>
@@ -5997,7 +6009,7 @@
                           </a:solidFill>
                           <a:latin typeface="Arial"/>
                         </a:rPr>
-                        <a:t>22</a:t>
+                        <a:t>23</a:t>
                       </a:r>
                     </a:p>
                   </a:txBody>
@@ -6020,7 +6032,7 @@
                           </a:solidFill>
                           <a:latin typeface="Arial"/>
                         </a:rPr>
-                        <a:t>10.2</a:t>
+                        <a:t>9.7</a:t>
                       </a:r>
                     </a:p>
                   </a:txBody>
@@ -6043,7 +6055,7 @@
                           </a:solidFill>
                           <a:latin typeface="Arial"/>
                         </a:rPr>
-                        <a:t>78%</a:t>
+                        <a:t>59%</a:t>
                       </a:r>
                     </a:p>
                   </a:txBody>
@@ -6091,7 +6103,7 @@
                           </a:solidFill>
                           <a:latin typeface="Arial"/>
                         </a:rPr>
-                        <a:t>Indiana</a:t>
+                        <a:t>Miami</a:t>
                       </a:r>
                     </a:p>
                   </a:txBody>
@@ -6114,76 +6126,76 @@
                           </a:solidFill>
                           <a:latin typeface="Arial"/>
                         </a:rPr>
-                        <a:t>Big Ten</a:t>
-                      </a:r>
-                    </a:p>
-                  </a:txBody>
-                  <a:tcPr>
-                    <a:solidFill>
-                      <a:srgbClr val="FFFFFF"/>
-                    </a:solidFill>
-                  </a:tcPr>
-                </a:tc>
-                <a:tc>
-                  <a:txBody>
-                    <a:bodyPr/>
-                    <a:lstStyle/>
-                    <a:p>
-                      <a:pPr algn="ctr"/>
-                      <a:r>
-                        <a:rPr sz="1000">
-                          <a:solidFill>
-                            <a:srgbClr val="16273D"/>
-                          </a:solidFill>
-                          <a:latin typeface="Arial"/>
-                        </a:rPr>
-                        <a:t>23</a:t>
-                      </a:r>
-                    </a:p>
-                  </a:txBody>
-                  <a:tcPr>
-                    <a:solidFill>
-                      <a:srgbClr val="FFFFFF"/>
-                    </a:solidFill>
-                  </a:tcPr>
-                </a:tc>
-                <a:tc>
-                  <a:txBody>
-                    <a:bodyPr/>
-                    <a:lstStyle/>
-                    <a:p>
-                      <a:pPr algn="ctr"/>
-                      <a:r>
-                        <a:rPr sz="1000">
-                          <a:solidFill>
-                            <a:srgbClr val="16273D"/>
-                          </a:solidFill>
-                          <a:latin typeface="Arial"/>
-                        </a:rPr>
-                        <a:t>10.2</a:t>
-                      </a:r>
-                    </a:p>
-                  </a:txBody>
-                  <a:tcPr>
-                    <a:solidFill>
-                      <a:srgbClr val="FFFFFF"/>
-                    </a:solidFill>
-                  </a:tcPr>
-                </a:tc>
-                <a:tc>
-                  <a:txBody>
-                    <a:bodyPr/>
-                    <a:lstStyle/>
-                    <a:p>
-                      <a:pPr algn="ctr"/>
-                      <a:r>
-                        <a:rPr sz="1000">
-                          <a:solidFill>
-                            <a:srgbClr val="16273D"/>
-                          </a:solidFill>
-                          <a:latin typeface="Arial"/>
-                        </a:rPr>
-                        <a:t>75%</a:t>
+                        <a:t>ACC</a:t>
+                      </a:r>
+                    </a:p>
+                  </a:txBody>
+                  <a:tcPr>
+                    <a:solidFill>
+                      <a:srgbClr val="FFFFFF"/>
+                    </a:solidFill>
+                  </a:tcPr>
+                </a:tc>
+                <a:tc>
+                  <a:txBody>
+                    <a:bodyPr/>
+                    <a:lstStyle/>
+                    <a:p>
+                      <a:pPr algn="ctr"/>
+                      <a:r>
+                        <a:rPr sz="1000">
+                          <a:solidFill>
+                            <a:srgbClr val="16273D"/>
+                          </a:solidFill>
+                          <a:latin typeface="Arial"/>
+                        </a:rPr>
+                        <a:t>22</a:t>
+                      </a:r>
+                    </a:p>
+                  </a:txBody>
+                  <a:tcPr>
+                    <a:solidFill>
+                      <a:srgbClr val="FFFFFF"/>
+                    </a:solidFill>
+                  </a:tcPr>
+                </a:tc>
+                <a:tc>
+                  <a:txBody>
+                    <a:bodyPr/>
+                    <a:lstStyle/>
+                    <a:p>
+                      <a:pPr algn="ctr"/>
+                      <a:r>
+                        <a:rPr sz="1000">
+                          <a:solidFill>
+                            <a:srgbClr val="16273D"/>
+                          </a:solidFill>
+                          <a:latin typeface="Arial"/>
+                        </a:rPr>
+                        <a:t>9.7</a:t>
+                      </a:r>
+                    </a:p>
+                  </a:txBody>
+                  <a:tcPr>
+                    <a:solidFill>
+                      <a:srgbClr val="FFFFFF"/>
+                    </a:solidFill>
+                  </a:tcPr>
+                </a:tc>
+                <a:tc>
+                  <a:txBody>
+                    <a:bodyPr/>
+                    <a:lstStyle/>
+                    <a:p>
+                      <a:pPr algn="ctr"/>
+                      <a:r>
+                        <a:rPr sz="1000">
+                          <a:solidFill>
+                            <a:srgbClr val="16273D"/>
+                          </a:solidFill>
+                          <a:latin typeface="Arial"/>
+                        </a:rPr>
+                        <a:t>58%</a:t>
                       </a:r>
                     </a:p>
                   </a:txBody>
@@ -6300,7 +6312,7 @@
                           </a:solidFill>
                           <a:latin typeface="Arial"/>
                         </a:rPr>
-                        <a:t>10.1</a:t>
+                        <a:t>9.6</a:t>
                       </a:r>
                     </a:p>
                   </a:txBody>
@@ -6323,7 +6335,7 @@
                           </a:solidFill>
                           <a:latin typeface="Arial"/>
                         </a:rPr>
-                        <a:t>71%</a:t>
+                        <a:t>56%</a:t>
                       </a:r>
                     </a:p>
                   </a:txBody>
@@ -6440,30 +6452,30 @@
                           </a:solidFill>
                           <a:latin typeface="Arial"/>
                         </a:rPr>
-                        <a:t>10.1</a:t>
-                      </a:r>
-                    </a:p>
-                  </a:txBody>
-                  <a:tcPr>
-                    <a:solidFill>
-                      <a:srgbClr val="FFFFFF"/>
-                    </a:solidFill>
-                  </a:tcPr>
-                </a:tc>
-                <a:tc>
-                  <a:txBody>
-                    <a:bodyPr/>
-                    <a:lstStyle/>
-                    <a:p>
-                      <a:pPr algn="ctr"/>
-                      <a:r>
-                        <a:rPr sz="1000">
-                          <a:solidFill>
-                            <a:srgbClr val="16273D"/>
-                          </a:solidFill>
-                          <a:latin typeface="Arial"/>
-                        </a:rPr>
-                        <a:t>70%</a:t>
+                        <a:t>9.4</a:t>
+                      </a:r>
+                    </a:p>
+                  </a:txBody>
+                  <a:tcPr>
+                    <a:solidFill>
+                      <a:srgbClr val="FFFFFF"/>
+                    </a:solidFill>
+                  </a:tcPr>
+                </a:tc>
+                <a:tc>
+                  <a:txBody>
+                    <a:bodyPr/>
+                    <a:lstStyle/>
+                    <a:p>
+                      <a:pPr algn="ctr"/>
+                      <a:r>
+                        <a:rPr sz="1000">
+                          <a:solidFill>
+                            <a:srgbClr val="16273D"/>
+                          </a:solidFill>
+                          <a:latin typeface="Arial"/>
+                        </a:rPr>
+                        <a:t>50%</a:t>
                       </a:r>
                     </a:p>
                   </a:txBody>
@@ -6580,7 +6592,7 @@
                           </a:solidFill>
                           <a:latin typeface="Arial"/>
                         </a:rPr>
-                        <a:t>9.7</a:t>
+                        <a:t>9.2</a:t>
                       </a:r>
                     </a:p>
                   </a:txBody>
@@ -6603,7 +6615,7 @@
                           </a:solidFill>
                           <a:latin typeface="Arial"/>
                         </a:rPr>
-                        <a:t>60%</a:t>
+                        <a:t>44%</a:t>
                       </a:r>
                     </a:p>
                   </a:txBody>
@@ -6720,30 +6732,30 @@
                           </a:solidFill>
                           <a:latin typeface="Arial"/>
                         </a:rPr>
-                        <a:t>9.3</a:t>
-                      </a:r>
-                    </a:p>
-                  </a:txBody>
-                  <a:tcPr>
-                    <a:solidFill>
-                      <a:srgbClr val="FFFFFF"/>
-                    </a:solidFill>
-                  </a:tcPr>
-                </a:tc>
-                <a:tc>
-                  <a:txBody>
-                    <a:bodyPr/>
-                    <a:lstStyle/>
-                    <a:p>
-                      <a:pPr algn="ctr"/>
-                      <a:r>
-                        <a:rPr sz="1000">
-                          <a:solidFill>
-                            <a:srgbClr val="16273D"/>
-                          </a:solidFill>
-                          <a:latin typeface="Arial"/>
-                        </a:rPr>
-                        <a:t>44%</a:t>
+                        <a:t>8.7</a:t>
+                      </a:r>
+                    </a:p>
+                  </a:txBody>
+                  <a:tcPr>
+                    <a:solidFill>
+                      <a:srgbClr val="FFFFFF"/>
+                    </a:solidFill>
+                  </a:tcPr>
+                </a:tc>
+                <a:tc>
+                  <a:txBody>
+                    <a:bodyPr/>
+                    <a:lstStyle/>
+                    <a:p>
+                      <a:pPr algn="ctr"/>
+                      <a:r>
+                        <a:rPr sz="1000">
+                          <a:solidFill>
+                            <a:srgbClr val="16273D"/>
+                          </a:solidFill>
+                          <a:latin typeface="Arial"/>
+                        </a:rPr>
+                        <a:t>31%</a:t>
                       </a:r>
                     </a:p>
                   </a:txBody>
@@ -6860,7 +6872,7 @@
                           </a:solidFill>
                           <a:latin typeface="Arial"/>
                         </a:rPr>
-                        <a:t>9.0</a:t>
+                        <a:t>8.4</a:t>
                       </a:r>
                     </a:p>
                   </a:txBody>
@@ -6883,7 +6895,7 @@
                           </a:solidFill>
                           <a:latin typeface="Arial"/>
                         </a:rPr>
-                        <a:t>38%</a:t>
+                        <a:t>25%</a:t>
                       </a:r>
                     </a:p>
                   </a:txBody>
@@ -6931,7 +6943,7 @@
                           </a:solidFill>
                           <a:latin typeface="Arial"/>
                         </a:rPr>
-                        <a:t>Alabama</a:t>
+                        <a:t>BYU</a:t>
                       </a:r>
                     </a:p>
                   </a:txBody>
@@ -6954,76 +6966,76 @@
                           </a:solidFill>
                           <a:latin typeface="Arial"/>
                         </a:rPr>
-                        <a:t>SEC</a:t>
-                      </a:r>
-                    </a:p>
-                  </a:txBody>
-                  <a:tcPr>
-                    <a:solidFill>
-                      <a:srgbClr val="FFFFFF"/>
-                    </a:solidFill>
-                  </a:tcPr>
-                </a:tc>
-                <a:tc>
-                  <a:txBody>
-                    <a:bodyPr/>
-                    <a:lstStyle/>
-                    <a:p>
-                      <a:pPr algn="ctr"/>
-                      <a:r>
-                        <a:rPr sz="1000">
-                          <a:solidFill>
-                            <a:srgbClr val="16273D"/>
-                          </a:solidFill>
-                          <a:latin typeface="Arial"/>
-                        </a:rPr>
-                        <a:t>20</a:t>
-                      </a:r>
-                    </a:p>
-                  </a:txBody>
-                  <a:tcPr>
-                    <a:solidFill>
-                      <a:srgbClr val="FFFFFF"/>
-                    </a:solidFill>
-                  </a:tcPr>
-                </a:tc>
-                <a:tc>
-                  <a:txBody>
-                    <a:bodyPr/>
-                    <a:lstStyle/>
-                    <a:p>
-                      <a:pPr algn="ctr"/>
-                      <a:r>
-                        <a:rPr sz="1000">
-                          <a:solidFill>
-                            <a:srgbClr val="16273D"/>
-                          </a:solidFill>
-                          <a:latin typeface="Arial"/>
-                        </a:rPr>
-                        <a:t>8.8</a:t>
-                      </a:r>
-                    </a:p>
-                  </a:txBody>
-                  <a:tcPr>
-                    <a:solidFill>
-                      <a:srgbClr val="FFFFFF"/>
-                    </a:solidFill>
-                  </a:tcPr>
-                </a:tc>
-                <a:tc>
-                  <a:txBody>
-                    <a:bodyPr/>
-                    <a:lstStyle/>
-                    <a:p>
-                      <a:pPr algn="ctr"/>
-                      <a:r>
-                        <a:rPr sz="1000">
-                          <a:solidFill>
-                            <a:srgbClr val="16273D"/>
-                          </a:solidFill>
-                          <a:latin typeface="Arial"/>
-                        </a:rPr>
-                        <a:t>31%</a:t>
+                        <a:t>Big 12</a:t>
+                      </a:r>
+                    </a:p>
+                  </a:txBody>
+                  <a:tcPr>
+                    <a:solidFill>
+                      <a:srgbClr val="FFFFFF"/>
+                    </a:solidFill>
+                  </a:tcPr>
+                </a:tc>
+                <a:tc>
+                  <a:txBody>
+                    <a:bodyPr/>
+                    <a:lstStyle/>
+                    <a:p>
+                      <a:pPr algn="ctr"/>
+                      <a:r>
+                        <a:rPr sz="1000">
+                          <a:solidFill>
+                            <a:srgbClr val="16273D"/>
+                          </a:solidFill>
+                          <a:latin typeface="Arial"/>
+                        </a:rPr>
+                        <a:t>13</a:t>
+                      </a:r>
+                    </a:p>
+                  </a:txBody>
+                  <a:tcPr>
+                    <a:solidFill>
+                      <a:srgbClr val="FFFFFF"/>
+                    </a:solidFill>
+                  </a:tcPr>
+                </a:tc>
+                <a:tc>
+                  <a:txBody>
+                    <a:bodyPr/>
+                    <a:lstStyle/>
+                    <a:p>
+                      <a:pPr algn="ctr"/>
+                      <a:r>
+                        <a:rPr sz="1000">
+                          <a:solidFill>
+                            <a:srgbClr val="16273D"/>
+                          </a:solidFill>
+                          <a:latin typeface="Arial"/>
+                        </a:rPr>
+                        <a:t>8.3</a:t>
+                      </a:r>
+                    </a:p>
+                  </a:txBody>
+                  <a:tcPr>
+                    <a:solidFill>
+                      <a:srgbClr val="FFFFFF"/>
+                    </a:solidFill>
+                  </a:tcPr>
+                </a:tc>
+                <a:tc>
+                  <a:txBody>
+                    <a:bodyPr/>
+                    <a:lstStyle/>
+                    <a:p>
+                      <a:pPr algn="ctr"/>
+                      <a:r>
+                        <a:rPr sz="1000">
+                          <a:solidFill>
+                            <a:srgbClr val="16273D"/>
+                          </a:solidFill>
+                          <a:latin typeface="Arial"/>
+                        </a:rPr>
+                        <a:t>22%</a:t>
                       </a:r>
                     </a:p>
                   </a:txBody>
@@ -7071,7 +7083,7 @@
                           </a:solidFill>
                           <a:latin typeface="Arial"/>
                         </a:rPr>
-                        <a:t>BYU</a:t>
+                        <a:t>Alabama</a:t>
                       </a:r>
                     </a:p>
                   </a:txBody>
@@ -7094,7 +7106,7 @@
                           </a:solidFill>
                           <a:latin typeface="Arial"/>
                         </a:rPr>
-                        <a:t>Big 12</a:t>
+                        <a:t>SEC</a:t>
                       </a:r>
                     </a:p>
                   </a:txBody>
@@ -7117,7 +7129,7 @@
                           </a:solidFill>
                           <a:latin typeface="Arial"/>
                         </a:rPr>
-                        <a:t>13</a:t>
+                        <a:t>20</a:t>
                       </a:r>
                     </a:p>
                   </a:txBody>
@@ -7140,7 +7152,7 @@
                           </a:solidFill>
                           <a:latin typeface="Arial"/>
                         </a:rPr>
-                        <a:t>8.8</a:t>
+                        <a:t>8.3</a:t>
                       </a:r>
                     </a:p>
                   </a:txBody>
@@ -7163,7 +7175,7 @@
                           </a:solidFill>
                           <a:latin typeface="Arial"/>
                         </a:rPr>
-                        <a:t>31%</a:t>
+                        <a:t>22%</a:t>
                       </a:r>
                     </a:p>
                   </a:txBody>
@@ -7280,30 +7292,30 @@
                           </a:solidFill>
                           <a:latin typeface="Arial"/>
                         </a:rPr>
-                        <a:t>8.6</a:t>
-                      </a:r>
-                    </a:p>
-                  </a:txBody>
-                  <a:tcPr>
-                    <a:solidFill>
-                      <a:srgbClr val="FFFFFF"/>
-                    </a:solidFill>
-                  </a:tcPr>
-                </a:tc>
-                <a:tc>
-                  <a:txBody>
-                    <a:bodyPr/>
-                    <a:lstStyle/>
-                    <a:p>
-                      <a:pPr algn="ctr"/>
-                      <a:r>
-                        <a:rPr sz="1000">
-                          <a:solidFill>
-                            <a:srgbClr val="16273D"/>
-                          </a:solidFill>
-                          <a:latin typeface="Arial"/>
-                        </a:rPr>
-                        <a:t>26%</a:t>
+                        <a:t>8.2</a:t>
+                      </a:r>
+                    </a:p>
+                  </a:txBody>
+                  <a:tcPr>
+                    <a:solidFill>
+                      <a:srgbClr val="FFFFFF"/>
+                    </a:solidFill>
+                  </a:tcPr>
+                </a:tc>
+                <a:tc>
+                  <a:txBody>
+                    <a:bodyPr/>
+                    <a:lstStyle/>
+                    <a:p>
+                      <a:pPr algn="ctr"/>
+                      <a:r>
+                        <a:rPr sz="1000">
+                          <a:solidFill>
+                            <a:srgbClr val="16273D"/>
+                          </a:solidFill>
+                          <a:latin typeface="Arial"/>
+                        </a:rPr>
+                        <a:t>20%</a:t>
                       </a:r>
                     </a:p>
                   </a:txBody>
@@ -7590,30 +7602,30 @@
                           </a:solidFill>
                           <a:latin typeface="Arial"/>
                         </a:rPr>
-                        <a:t>8.5</a:t>
-                      </a:r>
-                    </a:p>
-                  </a:txBody>
-                  <a:tcPr>
-                    <a:solidFill>
-                      <a:srgbClr val="FFFFFF"/>
-                    </a:solidFill>
-                  </a:tcPr>
-                </a:tc>
-                <a:tc>
-                  <a:txBody>
-                    <a:bodyPr/>
-                    <a:lstStyle/>
-                    <a:p>
-                      <a:pPr algn="ctr"/>
-                      <a:r>
-                        <a:rPr sz="1000">
-                          <a:solidFill>
-                            <a:srgbClr val="16273D"/>
-                          </a:solidFill>
-                          <a:latin typeface="Arial"/>
-                        </a:rPr>
-                        <a:t>26%</a:t>
+                        <a:t>8.2</a:t>
+                      </a:r>
+                    </a:p>
+                  </a:txBody>
+                  <a:tcPr>
+                    <a:solidFill>
+                      <a:srgbClr val="FFFFFF"/>
+                    </a:solidFill>
+                  </a:tcPr>
+                </a:tc>
+                <a:tc>
+                  <a:txBody>
+                    <a:bodyPr/>
+                    <a:lstStyle/>
+                    <a:p>
+                      <a:pPr algn="ctr"/>
+                      <a:r>
+                        <a:rPr sz="1000">
+                          <a:solidFill>
+                            <a:srgbClr val="16273D"/>
+                          </a:solidFill>
+                          <a:latin typeface="Arial"/>
+                        </a:rPr>
+                        <a:t>19%</a:t>
                       </a:r>
                     </a:p>
                   </a:txBody>
@@ -7730,7 +7742,7 @@
                           </a:solidFill>
                           <a:latin typeface="Arial"/>
                         </a:rPr>
-                        <a:t>8.5</a:t>
+                        <a:t>8.2</a:t>
                       </a:r>
                     </a:p>
                   </a:txBody>
@@ -7753,7 +7765,7 @@
                           </a:solidFill>
                           <a:latin typeface="Arial"/>
                         </a:rPr>
-                        <a:t>20%</a:t>
+                        <a:t>17%</a:t>
                       </a:r>
                     </a:p>
                   </a:txBody>
@@ -7870,30 +7882,30 @@
                           </a:solidFill>
                           <a:latin typeface="Arial"/>
                         </a:rPr>
-                        <a:t>8.4</a:t>
-                      </a:r>
-                    </a:p>
-                  </a:txBody>
-                  <a:tcPr>
-                    <a:solidFill>
-                      <a:srgbClr val="FFFFFF"/>
-                    </a:solidFill>
-                  </a:tcPr>
-                </a:tc>
-                <a:tc>
-                  <a:txBody>
-                    <a:bodyPr/>
-                    <a:lstStyle/>
-                    <a:p>
-                      <a:pPr algn="ctr"/>
-                      <a:r>
-                        <a:rPr sz="1000">
-                          <a:solidFill>
-                            <a:srgbClr val="16273D"/>
-                          </a:solidFill>
-                          <a:latin typeface="Arial"/>
-                        </a:rPr>
-                        <a:t>22%</a:t>
+                        <a:t>8.2</a:t>
+                      </a:r>
+                    </a:p>
+                  </a:txBody>
+                  <a:tcPr>
+                    <a:solidFill>
+                      <a:srgbClr val="FFFFFF"/>
+                    </a:solidFill>
+                  </a:tcPr>
+                </a:tc>
+                <a:tc>
+                  <a:txBody>
+                    <a:bodyPr/>
+                    <a:lstStyle/>
+                    <a:p>
+                      <a:pPr algn="ctr"/>
+                      <a:r>
+                        <a:rPr sz="1000">
+                          <a:solidFill>
+                            <a:srgbClr val="16273D"/>
+                          </a:solidFill>
+                          <a:latin typeface="Arial"/>
+                        </a:rPr>
+                        <a:t>18%</a:t>
                       </a:r>
                     </a:p>
                   </a:txBody>
@@ -7941,7 +7953,7 @@
                           </a:solidFill>
                           <a:latin typeface="Arial"/>
                         </a:rPr>
-                        <a:t>Toledo</a:t>
+                        <a:t>SMU</a:t>
                       </a:r>
                     </a:p>
                   </a:txBody>
@@ -7964,7 +7976,7 @@
                           </a:solidFill>
                           <a:latin typeface="Arial"/>
                         </a:rPr>
-                        <a:t>MAC</a:t>
+                        <a:t>ACC</a:t>
                       </a:r>
                     </a:p>
                   </a:txBody>
@@ -7987,7 +7999,7 @@
                           </a:solidFill>
                           <a:latin typeface="Arial"/>
                         </a:rPr>
-                        <a:t>-3</a:t>
+                        <a:t>11</a:t>
                       </a:r>
                     </a:p>
                   </a:txBody>
@@ -8010,7 +8022,7 @@
                           </a:solidFill>
                           <a:latin typeface="Arial"/>
                         </a:rPr>
-                        <a:t>8.4</a:t>
+                        <a:t>8.1</a:t>
                       </a:r>
                     </a:p>
                   </a:txBody>
@@ -8033,7 +8045,7 @@
                           </a:solidFill>
                           <a:latin typeface="Arial"/>
                         </a:rPr>
-                        <a:t>23%</a:t>
+                        <a:t>16%</a:t>
                       </a:r>
                     </a:p>
                   </a:txBody>
@@ -8081,7 +8093,7 @@
                           </a:solidFill>
                           <a:latin typeface="Arial"/>
                         </a:rPr>
-                        <a:t>SMU</a:t>
+                        <a:t>Toledo</a:t>
                       </a:r>
                     </a:p>
                   </a:txBody>
@@ -8104,76 +8116,76 @@
                           </a:solidFill>
                           <a:latin typeface="Arial"/>
                         </a:rPr>
-                        <a:t>ACC</a:t>
-                      </a:r>
-                    </a:p>
-                  </a:txBody>
-                  <a:tcPr>
-                    <a:solidFill>
-                      <a:srgbClr val="FFFFFF"/>
-                    </a:solidFill>
-                  </a:tcPr>
-                </a:tc>
-                <a:tc>
-                  <a:txBody>
-                    <a:bodyPr/>
-                    <a:lstStyle/>
-                    <a:p>
-                      <a:pPr algn="ctr"/>
-                      <a:r>
-                        <a:rPr sz="1000">
-                          <a:solidFill>
-                            <a:srgbClr val="16273D"/>
-                          </a:solidFill>
-                          <a:latin typeface="Arial"/>
-                        </a:rPr>
-                        <a:t>11</a:t>
-                      </a:r>
-                    </a:p>
-                  </a:txBody>
-                  <a:tcPr>
-                    <a:solidFill>
-                      <a:srgbClr val="FFFFFF"/>
-                    </a:solidFill>
-                  </a:tcPr>
-                </a:tc>
-                <a:tc>
-                  <a:txBody>
-                    <a:bodyPr/>
-                    <a:lstStyle/>
-                    <a:p>
-                      <a:pPr algn="ctr"/>
-                      <a:r>
-                        <a:rPr sz="1000">
-                          <a:solidFill>
-                            <a:srgbClr val="16273D"/>
-                          </a:solidFill>
-                          <a:latin typeface="Arial"/>
-                        </a:rPr>
-                        <a:t>8.4</a:t>
-                      </a:r>
-                    </a:p>
-                  </a:txBody>
-                  <a:tcPr>
-                    <a:solidFill>
-                      <a:srgbClr val="FFFFFF"/>
-                    </a:solidFill>
-                  </a:tcPr>
-                </a:tc>
-                <a:tc>
-                  <a:txBody>
-                    <a:bodyPr/>
-                    <a:lstStyle/>
-                    <a:p>
-                      <a:pPr algn="ctr"/>
-                      <a:r>
-                        <a:rPr sz="1000">
-                          <a:solidFill>
-                            <a:srgbClr val="16273D"/>
-                          </a:solidFill>
-                          <a:latin typeface="Arial"/>
-                        </a:rPr>
-                        <a:t>22%</a:t>
+                        <a:t>MAC</a:t>
+                      </a:r>
+                    </a:p>
+                  </a:txBody>
+                  <a:tcPr>
+                    <a:solidFill>
+                      <a:srgbClr val="FFFFFF"/>
+                    </a:solidFill>
+                  </a:tcPr>
+                </a:tc>
+                <a:tc>
+                  <a:txBody>
+                    <a:bodyPr/>
+                    <a:lstStyle/>
+                    <a:p>
+                      <a:pPr algn="ctr"/>
+                      <a:r>
+                        <a:rPr sz="1000">
+                          <a:solidFill>
+                            <a:srgbClr val="16273D"/>
+                          </a:solidFill>
+                          <a:latin typeface="Arial"/>
+                        </a:rPr>
+                        <a:t>-3</a:t>
+                      </a:r>
+                    </a:p>
+                  </a:txBody>
+                  <a:tcPr>
+                    <a:solidFill>
+                      <a:srgbClr val="FFFFFF"/>
+                    </a:solidFill>
+                  </a:tcPr>
+                </a:tc>
+                <a:tc>
+                  <a:txBody>
+                    <a:bodyPr/>
+                    <a:lstStyle/>
+                    <a:p>
+                      <a:pPr algn="ctr"/>
+                      <a:r>
+                        <a:rPr sz="1000">
+                          <a:solidFill>
+                            <a:srgbClr val="16273D"/>
+                          </a:solidFill>
+                          <a:latin typeface="Arial"/>
+                        </a:rPr>
+                        <a:t>8.0</a:t>
+                      </a:r>
+                    </a:p>
+                  </a:txBody>
+                  <a:tcPr>
+                    <a:solidFill>
+                      <a:srgbClr val="FFFFFF"/>
+                    </a:solidFill>
+                  </a:tcPr>
+                </a:tc>
+                <a:tc>
+                  <a:txBody>
+                    <a:bodyPr/>
+                    <a:lstStyle/>
+                    <a:p>
+                      <a:pPr algn="ctr"/>
+                      <a:r>
+                        <a:rPr sz="1000">
+                          <a:solidFill>
+                            <a:srgbClr val="16273D"/>
+                          </a:solidFill>
+                          <a:latin typeface="Arial"/>
+                        </a:rPr>
+                        <a:t>17%</a:t>
                       </a:r>
                     </a:p>
                   </a:txBody>
@@ -8221,7 +8233,7 @@
                           </a:solidFill>
                           <a:latin typeface="Arial"/>
                         </a:rPr>
-                        <a:t>Tulane</a:t>
+                        <a:t>Clemson</a:t>
                       </a:r>
                     </a:p>
                   </a:txBody>
@@ -8244,7 +8256,7 @@
                           </a:solidFill>
                           <a:latin typeface="Arial"/>
                         </a:rPr>
-                        <a:t>American</a:t>
+                        <a:t>ACC</a:t>
                       </a:r>
                     </a:p>
                   </a:txBody>
@@ -8267,7 +8279,7 @@
                           </a:solidFill>
                           <a:latin typeface="Arial"/>
                         </a:rPr>
-                        <a:t>2</a:t>
+                        <a:t>13</a:t>
                       </a:r>
                     </a:p>
                   </a:txBody>
@@ -8290,7 +8302,7 @@
                           </a:solidFill>
                           <a:latin typeface="Arial"/>
                         </a:rPr>
-                        <a:t>8.3</a:t>
+                        <a:t>8.0</a:t>
                       </a:r>
                     </a:p>
                   </a:txBody>
@@ -8313,7 +8325,7 @@
                           </a:solidFill>
                           <a:latin typeface="Arial"/>
                         </a:rPr>
-                        <a:t>22%</a:t>
+                        <a:t>15%</a:t>
                       </a:r>
                     </a:p>
                   </a:txBody>
@@ -8361,7 +8373,7 @@
                           </a:solidFill>
                           <a:latin typeface="Arial"/>
                         </a:rPr>
-                        <a:t>Clemson</a:t>
+                        <a:t>Tulane</a:t>
                       </a:r>
                     </a:p>
                   </a:txBody>
@@ -8384,76 +8396,76 @@
                           </a:solidFill>
                           <a:latin typeface="Arial"/>
                         </a:rPr>
-                        <a:t>ACC</a:t>
-                      </a:r>
-                    </a:p>
-                  </a:txBody>
-                  <a:tcPr>
-                    <a:solidFill>
-                      <a:srgbClr val="FFFFFF"/>
-                    </a:solidFill>
-                  </a:tcPr>
-                </a:tc>
-                <a:tc>
-                  <a:txBody>
-                    <a:bodyPr/>
-                    <a:lstStyle/>
-                    <a:p>
-                      <a:pPr algn="ctr"/>
-                      <a:r>
-                        <a:rPr sz="1000">
-                          <a:solidFill>
-                            <a:srgbClr val="16273D"/>
-                          </a:solidFill>
-                          <a:latin typeface="Arial"/>
-                        </a:rPr>
-                        <a:t>13</a:t>
-                      </a:r>
-                    </a:p>
-                  </a:txBody>
-                  <a:tcPr>
-                    <a:solidFill>
-                      <a:srgbClr val="FFFFFF"/>
-                    </a:solidFill>
-                  </a:tcPr>
-                </a:tc>
-                <a:tc>
-                  <a:txBody>
-                    <a:bodyPr/>
-                    <a:lstStyle/>
-                    <a:p>
-                      <a:pPr algn="ctr"/>
-                      <a:r>
-                        <a:rPr sz="1000">
-                          <a:solidFill>
-                            <a:srgbClr val="16273D"/>
-                          </a:solidFill>
-                          <a:latin typeface="Arial"/>
-                        </a:rPr>
-                        <a:t>8.3</a:t>
-                      </a:r>
-                    </a:p>
-                  </a:txBody>
-                  <a:tcPr>
-                    <a:solidFill>
-                      <a:srgbClr val="FFFFFF"/>
-                    </a:solidFill>
-                  </a:tcPr>
-                </a:tc>
-                <a:tc>
-                  <a:txBody>
-                    <a:bodyPr/>
-                    <a:lstStyle/>
-                    <a:p>
-                      <a:pPr algn="ctr"/>
-                      <a:r>
-                        <a:rPr sz="1000">
-                          <a:solidFill>
-                            <a:srgbClr val="16273D"/>
-                          </a:solidFill>
-                          <a:latin typeface="Arial"/>
-                        </a:rPr>
-                        <a:t>20%</a:t>
+                        <a:t>American</a:t>
+                      </a:r>
+                    </a:p>
+                  </a:txBody>
+                  <a:tcPr>
+                    <a:solidFill>
+                      <a:srgbClr val="FFFFFF"/>
+                    </a:solidFill>
+                  </a:tcPr>
+                </a:tc>
+                <a:tc>
+                  <a:txBody>
+                    <a:bodyPr/>
+                    <a:lstStyle/>
+                    <a:p>
+                      <a:pPr algn="ctr"/>
+                      <a:r>
+                        <a:rPr sz="1000">
+                          <a:solidFill>
+                            <a:srgbClr val="16273D"/>
+                          </a:solidFill>
+                          <a:latin typeface="Arial"/>
+                        </a:rPr>
+                        <a:t>2</a:t>
+                      </a:r>
+                    </a:p>
+                  </a:txBody>
+                  <a:tcPr>
+                    <a:solidFill>
+                      <a:srgbClr val="FFFFFF"/>
+                    </a:solidFill>
+                  </a:tcPr>
+                </a:tc>
+                <a:tc>
+                  <a:txBody>
+                    <a:bodyPr/>
+                    <a:lstStyle/>
+                    <a:p>
+                      <a:pPr algn="ctr"/>
+                      <a:r>
+                        <a:rPr sz="1000">
+                          <a:solidFill>
+                            <a:srgbClr val="16273D"/>
+                          </a:solidFill>
+                          <a:latin typeface="Arial"/>
+                        </a:rPr>
+                        <a:t>7.9</a:t>
+                      </a:r>
+                    </a:p>
+                  </a:txBody>
+                  <a:tcPr>
+                    <a:solidFill>
+                      <a:srgbClr val="FFFFFF"/>
+                    </a:solidFill>
+                  </a:tcPr>
+                </a:tc>
+                <a:tc>
+                  <a:txBody>
+                    <a:bodyPr/>
+                    <a:lstStyle/>
+                    <a:p>
+                      <a:pPr algn="ctr"/>
+                      <a:r>
+                        <a:rPr sz="1000">
+                          <a:solidFill>
+                            <a:srgbClr val="16273D"/>
+                          </a:solidFill>
+                          <a:latin typeface="Arial"/>
+                        </a:rPr>
+                        <a:t>15%</a:t>
                       </a:r>
                     </a:p>
                   </a:txBody>
@@ -8570,7 +8582,7 @@
                           </a:solidFill>
                           <a:latin typeface="Arial"/>
                         </a:rPr>
-                        <a:t>8.2</a:t>
+                        <a:t>7.9</a:t>
                       </a:r>
                     </a:p>
                   </a:txBody>
@@ -8593,7 +8605,7 @@
                           </a:solidFill>
                           <a:latin typeface="Arial"/>
                         </a:rPr>
-                        <a:t>19%</a:t>
+                        <a:t>15%</a:t>
                       </a:r>
                     </a:p>
                   </a:txBody>
@@ -8641,7 +8653,7 @@
                           </a:solidFill>
                           <a:latin typeface="Arial"/>
                         </a:rPr>
-                        <a:t>East Carolina</a:t>
+                        <a:t>Michigan</a:t>
                       </a:r>
                     </a:p>
                   </a:txBody>
@@ -8664,76 +8676,76 @@
                           </a:solidFill>
                           <a:latin typeface="Arial"/>
                         </a:rPr>
-                        <a:t>American</a:t>
-                      </a:r>
-                    </a:p>
-                  </a:txBody>
-                  <a:tcPr>
-                    <a:solidFill>
-                      <a:srgbClr val="FFFFFF"/>
-                    </a:solidFill>
-                  </a:tcPr>
-                </a:tc>
-                <a:tc>
-                  <a:txBody>
-                    <a:bodyPr/>
-                    <a:lstStyle/>
-                    <a:p>
-                      <a:pPr algn="ctr"/>
-                      <a:r>
-                        <a:rPr sz="1000">
-                          <a:solidFill>
-                            <a:srgbClr val="16273D"/>
-                          </a:solidFill>
-                          <a:latin typeface="Arial"/>
-                        </a:rPr>
-                        <a:t>-1</a:t>
-                      </a:r>
-                    </a:p>
-                  </a:txBody>
-                  <a:tcPr>
-                    <a:solidFill>
-                      <a:srgbClr val="FFFFFF"/>
-                    </a:solidFill>
-                  </a:tcPr>
-                </a:tc>
-                <a:tc>
-                  <a:txBody>
-                    <a:bodyPr/>
-                    <a:lstStyle/>
-                    <a:p>
-                      <a:pPr algn="ctr"/>
-                      <a:r>
-                        <a:rPr sz="1000">
-                          <a:solidFill>
-                            <a:srgbClr val="16273D"/>
-                          </a:solidFill>
-                          <a:latin typeface="Arial"/>
-                        </a:rPr>
-                        <a:t>8.1</a:t>
-                      </a:r>
-                    </a:p>
-                  </a:txBody>
-                  <a:tcPr>
-                    <a:solidFill>
-                      <a:srgbClr val="FFFFFF"/>
-                    </a:solidFill>
-                  </a:tcPr>
-                </a:tc>
-                <a:tc>
-                  <a:txBody>
-                    <a:bodyPr/>
-                    <a:lstStyle/>
-                    <a:p>
-                      <a:pPr algn="ctr"/>
-                      <a:r>
-                        <a:rPr sz="1000">
-                          <a:solidFill>
-                            <a:srgbClr val="16273D"/>
-                          </a:solidFill>
-                          <a:latin typeface="Arial"/>
-                        </a:rPr>
-                        <a:t>15%</a:t>
+                        <a:t>Big Ten</a:t>
+                      </a:r>
+                    </a:p>
+                  </a:txBody>
+                  <a:tcPr>
+                    <a:solidFill>
+                      <a:srgbClr val="FFFFFF"/>
+                    </a:solidFill>
+                  </a:tcPr>
+                </a:tc>
+                <a:tc>
+                  <a:txBody>
+                    <a:bodyPr/>
+                    <a:lstStyle/>
+                    <a:p>
+                      <a:pPr algn="ctr"/>
+                      <a:r>
+                        <a:rPr sz="1000">
+                          <a:solidFill>
+                            <a:srgbClr val="16273D"/>
+                          </a:solidFill>
+                          <a:latin typeface="Arial"/>
+                        </a:rPr>
+                        <a:t>16</a:t>
+                      </a:r>
+                    </a:p>
+                  </a:txBody>
+                  <a:tcPr>
+                    <a:solidFill>
+                      <a:srgbClr val="FFFFFF"/>
+                    </a:solidFill>
+                  </a:tcPr>
+                </a:tc>
+                <a:tc>
+                  <a:txBody>
+                    <a:bodyPr/>
+                    <a:lstStyle/>
+                    <a:p>
+                      <a:pPr algn="ctr"/>
+                      <a:r>
+                        <a:rPr sz="1000">
+                          <a:solidFill>
+                            <a:srgbClr val="16273D"/>
+                          </a:solidFill>
+                          <a:latin typeface="Arial"/>
+                        </a:rPr>
+                        <a:t>7.7</a:t>
+                      </a:r>
+                    </a:p>
+                  </a:txBody>
+                  <a:tcPr>
+                    <a:solidFill>
+                      <a:srgbClr val="FFFFFF"/>
+                    </a:solidFill>
+                  </a:tcPr>
+                </a:tc>
+                <a:tc>
+                  <a:txBody>
+                    <a:bodyPr/>
+                    <a:lstStyle/>
+                    <a:p>
+                      <a:pPr algn="ctr"/>
+                      <a:r>
+                        <a:rPr sz="1000">
+                          <a:solidFill>
+                            <a:srgbClr val="16273D"/>
+                          </a:solidFill>
+                          <a:latin typeface="Arial"/>
+                        </a:rPr>
+                        <a:t>11%</a:t>
                       </a:r>
                     </a:p>
                   </a:txBody>
@@ -8781,7 +8793,7 @@
                           </a:solidFill>
                           <a:latin typeface="Arial"/>
                         </a:rPr>
-                        <a:t>Navy</a:t>
+                        <a:t>East Carolina</a:t>
                       </a:r>
                     </a:p>
                   </a:txBody>
@@ -8850,7 +8862,7 @@
                           </a:solidFill>
                           <a:latin typeface="Arial"/>
                         </a:rPr>
-                        <a:t>8.1</a:t>
+                        <a:t>7.7</a:t>
                       </a:r>
                     </a:p>
                   </a:txBody>
@@ -8873,7 +8885,7 @@
                           </a:solidFill>
                           <a:latin typeface="Arial"/>
                         </a:rPr>
-                        <a:t>16%</a:t>
+                        <a:t>11%</a:t>
                       </a:r>
                     </a:p>
                   </a:txBody>
@@ -8921,7 +8933,7 @@
                           </a:solidFill>
                           <a:latin typeface="Arial"/>
                         </a:rPr>
-                        <a:t>Hawai'i</a:t>
+                        <a:t>Navy</a:t>
                       </a:r>
                     </a:p>
                   </a:txBody>
@@ -8944,76 +8956,76 @@
                           </a:solidFill>
                           <a:latin typeface="Arial"/>
                         </a:rPr>
-                        <a:t>MWC</a:t>
-                      </a:r>
-                    </a:p>
-                  </a:txBody>
-                  <a:tcPr>
-                    <a:solidFill>
-                      <a:srgbClr val="FFFFFF"/>
-                    </a:solidFill>
-                  </a:tcPr>
-                </a:tc>
-                <a:tc>
-                  <a:txBody>
-                    <a:bodyPr/>
-                    <a:lstStyle/>
-                    <a:p>
-                      <a:pPr algn="ctr"/>
-                      <a:r>
-                        <a:rPr sz="1000">
-                          <a:solidFill>
-                            <a:srgbClr val="16273D"/>
-                          </a:solidFill>
-                          <a:latin typeface="Arial"/>
-                        </a:rPr>
-                        <a:t>-2</a:t>
-                      </a:r>
-                    </a:p>
-                  </a:txBody>
-                  <a:tcPr>
-                    <a:solidFill>
-                      <a:srgbClr val="FFFFFF"/>
-                    </a:solidFill>
-                  </a:tcPr>
-                </a:tc>
-                <a:tc>
-                  <a:txBody>
-                    <a:bodyPr/>
-                    <a:lstStyle/>
-                    <a:p>
-                      <a:pPr algn="ctr"/>
-                      <a:r>
-                        <a:rPr sz="1000">
-                          <a:solidFill>
-                            <a:srgbClr val="16273D"/>
-                          </a:solidFill>
-                          <a:latin typeface="Arial"/>
-                        </a:rPr>
-                        <a:t>8.0</a:t>
-                      </a:r>
-                    </a:p>
-                  </a:txBody>
-                  <a:tcPr>
-                    <a:solidFill>
-                      <a:srgbClr val="FFFFFF"/>
-                    </a:solidFill>
-                  </a:tcPr>
-                </a:tc>
-                <a:tc>
-                  <a:txBody>
-                    <a:bodyPr/>
-                    <a:lstStyle/>
-                    <a:p>
-                      <a:pPr algn="ctr"/>
-                      <a:r>
-                        <a:rPr sz="1000">
-                          <a:solidFill>
-                            <a:srgbClr val="16273D"/>
-                          </a:solidFill>
-                          <a:latin typeface="Arial"/>
-                        </a:rPr>
-                        <a:t>15%</a:t>
+                        <a:t>American</a:t>
+                      </a:r>
+                    </a:p>
+                  </a:txBody>
+                  <a:tcPr>
+                    <a:solidFill>
+                      <a:srgbClr val="FFFFFF"/>
+                    </a:solidFill>
+                  </a:tcPr>
+                </a:tc>
+                <a:tc>
+                  <a:txBody>
+                    <a:bodyPr/>
+                    <a:lstStyle/>
+                    <a:p>
+                      <a:pPr algn="ctr"/>
+                      <a:r>
+                        <a:rPr sz="1000">
+                          <a:solidFill>
+                            <a:srgbClr val="16273D"/>
+                          </a:solidFill>
+                          <a:latin typeface="Arial"/>
+                        </a:rPr>
+                        <a:t>-1</a:t>
+                      </a:r>
+                    </a:p>
+                  </a:txBody>
+                  <a:tcPr>
+                    <a:solidFill>
+                      <a:srgbClr val="FFFFFF"/>
+                    </a:solidFill>
+                  </a:tcPr>
+                </a:tc>
+                <a:tc>
+                  <a:txBody>
+                    <a:bodyPr/>
+                    <a:lstStyle/>
+                    <a:p>
+                      <a:pPr algn="ctr"/>
+                      <a:r>
+                        <a:rPr sz="1000">
+                          <a:solidFill>
+                            <a:srgbClr val="16273D"/>
+                          </a:solidFill>
+                          <a:latin typeface="Arial"/>
+                        </a:rPr>
+                        <a:t>7.7</a:t>
+                      </a:r>
+                    </a:p>
+                  </a:txBody>
+                  <a:tcPr>
+                    <a:solidFill>
+                      <a:srgbClr val="FFFFFF"/>
+                    </a:solidFill>
+                  </a:tcPr>
+                </a:tc>
+                <a:tc>
+                  <a:txBody>
+                    <a:bodyPr/>
+                    <a:lstStyle/>
+                    <a:p>
+                      <a:pPr algn="ctr"/>
+                      <a:r>
+                        <a:rPr sz="1000">
+                          <a:solidFill>
+                            <a:srgbClr val="16273D"/>
+                          </a:solidFill>
+                          <a:latin typeface="Arial"/>
+                        </a:rPr>
+                        <a:t>10%</a:t>
                       </a:r>
                     </a:p>
                   </a:txBody>
@@ -9061,7 +9073,7 @@
                           </a:solidFill>
                           <a:latin typeface="Arial"/>
                         </a:rPr>
-                        <a:t>Michigan</a:t>
+                        <a:t>Virginia</a:t>
                       </a:r>
                     </a:p>
                   </a:txBody>
@@ -9084,7 +9096,7 @@
                           </a:solidFill>
                           <a:latin typeface="Arial"/>
                         </a:rPr>
-                        <a:t>Big Ten</a:t>
+                        <a:t>ACC</a:t>
                       </a:r>
                     </a:p>
                   </a:txBody>
@@ -9107,7 +9119,7 @@
                           </a:solidFill>
                           <a:latin typeface="Arial"/>
                         </a:rPr>
-                        <a:t>16</a:t>
+                        <a:t>8</a:t>
                       </a:r>
                     </a:p>
                   </a:txBody>
@@ -9130,7 +9142,7 @@
                           </a:solidFill>
                           <a:latin typeface="Arial"/>
                         </a:rPr>
-                        <a:t>8.0</a:t>
+                        <a:t>7.6</a:t>
                       </a:r>
                     </a:p>
                   </a:txBody>

</xml_diff>